<commit_message>
Refactor Test1 to accept a filename parameter for template processing and update related method calls; enhance SlideTextExtractor and DataBinder for improved handling of Korean text and expression processing.
</commit_message>
<xml_diff>
--- a/src/DocuChef.TestConsoleApp/files/ppt/TEST.pptx
+++ b/src/DocuChef.TestConsoleApp/files/ppt/TEST.pptx
@@ -441,7 +441,7 @@
           <a:p>
             <a:fld id="{AD7254AC-5C10-4D4D-8ECD-7B1A95607E92}" type="datetimeFigureOut">
               <a:rPr lang="ko-KR" altLang="en-US" smtClean="0"/>
-              <a:t>2025-05-28</a:t>
+              <a:t>2025-05-29</a:t>
             </a:fld>
             <a:endParaRPr lang="ko-KR" altLang="en-US"/>
           </a:p>
@@ -1047,7 +1047,7 @@
           <a:p>
             <a:fld id="{DB838EC2-E995-4149-B336-1846A9B9A433}" type="datetimeFigureOut">
               <a:rPr lang="ko-KR" altLang="en-US" smtClean="0"/>
-              <a:t>2025-05-28</a:t>
+              <a:t>2025-05-29</a:t>
             </a:fld>
             <a:endParaRPr lang="ko-KR" altLang="en-US"/>
           </a:p>
@@ -1245,7 +1245,7 @@
           <a:p>
             <a:fld id="{DB838EC2-E995-4149-B336-1846A9B9A433}" type="datetimeFigureOut">
               <a:rPr lang="ko-KR" altLang="en-US" smtClean="0"/>
-              <a:t>2025-05-28</a:t>
+              <a:t>2025-05-29</a:t>
             </a:fld>
             <a:endParaRPr lang="ko-KR" altLang="en-US"/>
           </a:p>
@@ -1453,7 +1453,7 @@
           <a:p>
             <a:fld id="{DB838EC2-E995-4149-B336-1846A9B9A433}" type="datetimeFigureOut">
               <a:rPr lang="ko-KR" altLang="en-US" smtClean="0"/>
-              <a:t>2025-05-28</a:t>
+              <a:t>2025-05-29</a:t>
             </a:fld>
             <a:endParaRPr lang="ko-KR" altLang="en-US"/>
           </a:p>
@@ -1651,7 +1651,7 @@
           <a:p>
             <a:fld id="{DB838EC2-E995-4149-B336-1846A9B9A433}" type="datetimeFigureOut">
               <a:rPr lang="ko-KR" altLang="en-US" smtClean="0"/>
-              <a:t>2025-05-28</a:t>
+              <a:t>2025-05-29</a:t>
             </a:fld>
             <a:endParaRPr lang="ko-KR" altLang="en-US"/>
           </a:p>
@@ -1926,7 +1926,7 @@
           <a:p>
             <a:fld id="{DB838EC2-E995-4149-B336-1846A9B9A433}" type="datetimeFigureOut">
               <a:rPr lang="ko-KR" altLang="en-US" smtClean="0"/>
-              <a:t>2025-05-28</a:t>
+              <a:t>2025-05-29</a:t>
             </a:fld>
             <a:endParaRPr lang="ko-KR" altLang="en-US"/>
           </a:p>
@@ -2191,7 +2191,7 @@
           <a:p>
             <a:fld id="{DB838EC2-E995-4149-B336-1846A9B9A433}" type="datetimeFigureOut">
               <a:rPr lang="ko-KR" altLang="en-US" smtClean="0"/>
-              <a:t>2025-05-28</a:t>
+              <a:t>2025-05-29</a:t>
             </a:fld>
             <a:endParaRPr lang="ko-KR" altLang="en-US"/>
           </a:p>
@@ -2603,7 +2603,7 @@
           <a:p>
             <a:fld id="{DB838EC2-E995-4149-B336-1846A9B9A433}" type="datetimeFigureOut">
               <a:rPr lang="ko-KR" altLang="en-US" smtClean="0"/>
-              <a:t>2025-05-28</a:t>
+              <a:t>2025-05-29</a:t>
             </a:fld>
             <a:endParaRPr lang="ko-KR" altLang="en-US"/>
           </a:p>
@@ -2744,7 +2744,7 @@
           <a:p>
             <a:fld id="{DB838EC2-E995-4149-B336-1846A9B9A433}" type="datetimeFigureOut">
               <a:rPr lang="ko-KR" altLang="en-US" smtClean="0"/>
-              <a:t>2025-05-28</a:t>
+              <a:t>2025-05-29</a:t>
             </a:fld>
             <a:endParaRPr lang="ko-KR" altLang="en-US"/>
           </a:p>
@@ -2857,7 +2857,7 @@
           <a:p>
             <a:fld id="{DB838EC2-E995-4149-B336-1846A9B9A433}" type="datetimeFigureOut">
               <a:rPr lang="ko-KR" altLang="en-US" smtClean="0"/>
-              <a:t>2025-05-28</a:t>
+              <a:t>2025-05-29</a:t>
             </a:fld>
             <a:endParaRPr lang="ko-KR" altLang="en-US"/>
           </a:p>
@@ -3168,7 +3168,7 @@
           <a:p>
             <a:fld id="{DB838EC2-E995-4149-B336-1846A9B9A433}" type="datetimeFigureOut">
               <a:rPr lang="ko-KR" altLang="en-US" smtClean="0"/>
-              <a:t>2025-05-28</a:t>
+              <a:t>2025-05-29</a:t>
             </a:fld>
             <a:endParaRPr lang="ko-KR" altLang="en-US"/>
           </a:p>
@@ -3456,7 +3456,7 @@
           <a:p>
             <a:fld id="{DB838EC2-E995-4149-B336-1846A9B9A433}" type="datetimeFigureOut">
               <a:rPr lang="ko-KR" altLang="en-US" smtClean="0"/>
-              <a:t>2025-05-28</a:t>
+              <a:t>2025-05-29</a:t>
             </a:fld>
             <a:endParaRPr lang="ko-KR" altLang="en-US"/>
           </a:p>
@@ -3697,7 +3697,7 @@
           <a:p>
             <a:fld id="{DB838EC2-E995-4149-B336-1846A9B9A433}" type="datetimeFigureOut">
               <a:rPr lang="ko-KR" altLang="en-US" smtClean="0"/>
-              <a:t>2025-05-28</a:t>
+              <a:t>2025-05-29</a:t>
             </a:fld>
             <a:endParaRPr lang="ko-KR" altLang="en-US"/>
           </a:p>
@@ -4132,14 +4132,20 @@
         </p:nvSpPr>
         <p:spPr/>
         <p:txBody>
-          <a:bodyPr/>
-          <a:lstStyle/>
-          <a:p>
-            <a:r>
-              <a:rPr lang="en-US" altLang="ko-KR"/>
-              <a:t>${Today:yyyy-MM-dd}</a:t>
-            </a:r>
-            <a:endParaRPr lang="ko-KR" altLang="en-US"/>
+          <a:bodyPr>
+            <a:normAutofit/>
+          </a:bodyPr>
+          <a:lstStyle/>
+          <a:p>
+            <a:r>
+              <a:rPr lang="en-US" altLang="ko-KR" sz="3200" b="1"/>
+              <a:t>Product Catalogs</a:t>
+            </a:r>
+            <a:r>
+              <a:rPr lang="en-US" altLang="ko-KR" sz="3200"/>
+              <a:t>(${Today:yyyy-MM-dd})</a:t>
+            </a:r>
+            <a:endParaRPr lang="ko-KR" altLang="en-US" sz="3200"/>
           </a:p>
         </p:txBody>
       </p:sp>

</xml_diff>